<commit_message>
Verouderde teksten ontwikkelgesprekken: knop Spelers, privacytekst, module-naam, handleidingen (Besluit 74)
Co-Authored-By: Claude Opus 5.5 <noreply@anthropic.com>
Claude-Session: https://claude.ai/code/session_01JemqRo5kiX7AhhtzuggotQ
</commit_message>
<xml_diff>
--- a/docs/presentaties/ClubComm-trainer.pptx
+++ b/docs/presentaties/ClubComm-trainer.pptx
@@ -3333,7 +3333,7 @@
                 <a:ea typeface="Calibri" pitchFamily="34" charset="-122"/>
                 <a:cs typeface="Calibri" pitchFamily="34" charset="-120"/>
               </a:rPr>
-              <a:t>Beoordelen</a:t>
+              <a:t>Ontwikkelgesprek</a:t>
             </a:r>
             <a:endParaRPr lang="en-US" sz="1700" dirty="0"/>
           </a:p>
@@ -3350,7 +3350,7 @@
                 <a:ea typeface="Calibri" pitchFamily="34" charset="-122"/>
                 <a:cs typeface="Calibri" pitchFamily="34" charset="-120"/>
               </a:rPr>
-              <a:t>Twee keer per seizoen, passend bij de leeftijd. Ouders zien alleen hun eigen kind.</a:t>
+              <a:t>Start en voorjaar, 15 minuten rond de training. Jij zet tijden klaar, ouders kiezen zelf.</a:t>
             </a:r>
             <a:endParaRPr lang="en-US" sz="1700" dirty="0"/>
           </a:p>
@@ -3455,7 +3455,7 @@
                 <a:ea typeface="Calibri" pitchFamily="34" charset="-122"/>
                 <a:cs typeface="Calibri" pitchFamily="34" charset="-120"/>
               </a:rPr>
-              <a:t>Ontwikkelgesprek</a:t>
+              <a:t>Kind aan zet</a:t>
             </a:r>
             <a:endParaRPr lang="en-US" sz="1700" dirty="0"/>
           </a:p>
@@ -3472,7 +3472,7 @@
                 <a:ea typeface="Calibri" pitchFamily="34" charset="-122"/>
                 <a:cs typeface="Calibri" pitchFamily="34" charset="-120"/>
               </a:rPr>
-              <a:t>Na het beoordelen plan je een gesprek met ouder en kind. Ouders kiezen zelf een tijd.</a:t>
+              <a:t>Thuis vult het kind een opdracht in (sterk, wapen, beter worden). In het gesprek vraag jij door; samen kies je 2 doelen.</a:t>
             </a:r>
             <a:endParaRPr lang="en-US" sz="1700" dirty="0"/>
           </a:p>
@@ -4899,7 +4899,7 @@
                 <a:ea typeface="Calibri" pitchFamily="34" charset="-122"/>
                 <a:cs typeface="Calibri" pitchFamily="34" charset="-120"/>
               </a:rPr>
-              <a:t>Beoordelen en ontwikkelgesprekken op vaste momenten in het seizoen.</a:t>
+              <a:t>Ontwikkelgesprekken vanaf O12: het kind kiest zelf zijn wapen en doelen.</a:t>
             </a:r>
             <a:endParaRPr lang="en-US" sz="1700" dirty="0"/>
           </a:p>

</xml_diff>